<commit_message>
updated materials for 2026
</commit_message>
<xml_diff>
--- a/übungsmaterialien/ai-applications.pptx
+++ b/übungsmaterialien/ai-applications.pptx
@@ -268,7 +268,7 @@
           <a:p>
             <a:fld id="{8F949F18-88FA-9643-81FA-04A43E26893D}" type="datetimeFigureOut">
               <a:rPr lang="en-DE" smtClean="0"/>
-              <a:t>02.10.25</a:t>
+              <a:t>19.10.26</a:t>
             </a:fld>
             <a:endParaRPr lang="en-DE"/>
           </a:p>
@@ -468,7 +468,7 @@
           <a:p>
             <a:fld id="{8F949F18-88FA-9643-81FA-04A43E26893D}" type="datetimeFigureOut">
               <a:rPr lang="en-DE" smtClean="0"/>
-              <a:t>02.10.25</a:t>
+              <a:t>19.10.26</a:t>
             </a:fld>
             <a:endParaRPr lang="en-DE"/>
           </a:p>
@@ -678,7 +678,7 @@
           <a:p>
             <a:fld id="{8F949F18-88FA-9643-81FA-04A43E26893D}" type="datetimeFigureOut">
               <a:rPr lang="en-DE" smtClean="0"/>
-              <a:t>02.10.25</a:t>
+              <a:t>19.10.26</a:t>
             </a:fld>
             <a:endParaRPr lang="en-DE"/>
           </a:p>
@@ -878,7 +878,7 @@
           <a:p>
             <a:fld id="{8F949F18-88FA-9643-81FA-04A43E26893D}" type="datetimeFigureOut">
               <a:rPr lang="en-DE" smtClean="0"/>
-              <a:t>02.10.25</a:t>
+              <a:t>19.10.26</a:t>
             </a:fld>
             <a:endParaRPr lang="en-DE"/>
           </a:p>
@@ -1154,7 +1154,7 @@
           <a:p>
             <a:fld id="{8F949F18-88FA-9643-81FA-04A43E26893D}" type="datetimeFigureOut">
               <a:rPr lang="en-DE" smtClean="0"/>
-              <a:t>02.10.25</a:t>
+              <a:t>19.10.26</a:t>
             </a:fld>
             <a:endParaRPr lang="en-DE"/>
           </a:p>
@@ -1422,7 +1422,7 @@
           <a:p>
             <a:fld id="{8F949F18-88FA-9643-81FA-04A43E26893D}" type="datetimeFigureOut">
               <a:rPr lang="en-DE" smtClean="0"/>
-              <a:t>02.10.25</a:t>
+              <a:t>19.10.26</a:t>
             </a:fld>
             <a:endParaRPr lang="en-DE"/>
           </a:p>
@@ -1837,7 +1837,7 @@
           <a:p>
             <a:fld id="{8F949F18-88FA-9643-81FA-04A43E26893D}" type="datetimeFigureOut">
               <a:rPr lang="en-DE" smtClean="0"/>
-              <a:t>02.10.25</a:t>
+              <a:t>19.10.26</a:t>
             </a:fld>
             <a:endParaRPr lang="en-DE"/>
           </a:p>
@@ -1979,7 +1979,7 @@
           <a:p>
             <a:fld id="{8F949F18-88FA-9643-81FA-04A43E26893D}" type="datetimeFigureOut">
               <a:rPr lang="en-DE" smtClean="0"/>
-              <a:t>02.10.25</a:t>
+              <a:t>19.10.26</a:t>
             </a:fld>
             <a:endParaRPr lang="en-DE"/>
           </a:p>
@@ -2092,7 +2092,7 @@
           <a:p>
             <a:fld id="{8F949F18-88FA-9643-81FA-04A43E26893D}" type="datetimeFigureOut">
               <a:rPr lang="en-DE" smtClean="0"/>
-              <a:t>02.10.25</a:t>
+              <a:t>19.10.26</a:t>
             </a:fld>
             <a:endParaRPr lang="en-DE"/>
           </a:p>
@@ -2405,7 +2405,7 @@
           <a:p>
             <a:fld id="{8F949F18-88FA-9643-81FA-04A43E26893D}" type="datetimeFigureOut">
               <a:rPr lang="en-DE" smtClean="0"/>
-              <a:t>02.10.25</a:t>
+              <a:t>19.10.26</a:t>
             </a:fld>
             <a:endParaRPr lang="en-DE"/>
           </a:p>
@@ -2694,7 +2694,7 @@
           <a:p>
             <a:fld id="{8F949F18-88FA-9643-81FA-04A43E26893D}" type="datetimeFigureOut">
               <a:rPr lang="en-DE" smtClean="0"/>
-              <a:t>02.10.25</a:t>
+              <a:t>19.10.26</a:t>
             </a:fld>
             <a:endParaRPr lang="en-DE"/>
           </a:p>
@@ -2937,7 +2937,7 @@
           <a:p>
             <a:fld id="{8F949F18-88FA-9643-81FA-04A43E26893D}" type="datetimeFigureOut">
               <a:rPr lang="en-DE" smtClean="0"/>
-              <a:t>02.10.25</a:t>
+              <a:t>19.10.26</a:t>
             </a:fld>
             <a:endParaRPr lang="en-DE"/>
           </a:p>
@@ -3579,7 +3579,7 @@
         </p:spPr>
         <p:txBody>
           <a:bodyPr anchor="ctr">
-            <a:normAutofit/>
+            <a:normAutofit fontScale="90000"/>
           </a:bodyPr>
           <a:lstStyle/>
           <a:p>
@@ -3588,7 +3588,7 @@
                 <a:latin typeface="Fira Sans" panose="020B0503050000020004" pitchFamily="34" charset="0"/>
                 <a:ea typeface="Fira Sans" panose="020B0503050000020004" pitchFamily="34" charset="0"/>
               </a:rPr>
-              <a:t>Content-Moderation von Misinformation</a:t>
+              <a:t>Moderation von Misinformation auf Social Media</a:t>
             </a:r>
           </a:p>
         </p:txBody>

</xml_diff>